<commit_message>
Update lesson 1 presentation and intro notebook
Co-Authored-By: Claude Opus 5.5 <noreply@anthropic.com>
</commit_message>
<xml_diff>
--- a/presenations/Bayesian models les1.pptx
+++ b/presenations/Bayesian models les1.pptx
@@ -127,6 +127,11 @@
       </a:defRPr>
     </a:lvl9pPr>
   </p:defaultTextStyle>
+  <p:extLst>
+    <p:ext uri="{EFAFB233-063F-42B5-8137-9DF3F51BA10A}">
+      <p15:sldGuideLst xmlns:p15="http://schemas.microsoft.com/office/powerpoint/2012/main"/>
+    </p:ext>
+  </p:extLst>
 </p:presentation>
 </file>
 
@@ -293,7 +298,7 @@
           <a:p>
             <a:fld id="{85F2A0FB-C061-41D3-B0AC-214264C195BD}" type="datetimeFigureOut">
               <a:rPr lang="en-IL" smtClean="0"/>
-              <a:t>03/03/2025</a:t>
+              <a:t>15/10/2026</a:t>
             </a:fld>
             <a:endParaRPr lang="en-IL"/>
           </a:p>
@@ -463,7 +468,7 @@
           <a:p>
             <a:fld id="{85F2A0FB-C061-41D3-B0AC-214264C195BD}" type="datetimeFigureOut">
               <a:rPr lang="en-IL" smtClean="0"/>
-              <a:t>03/03/2025</a:t>
+              <a:t>15/10/2026</a:t>
             </a:fld>
             <a:endParaRPr lang="en-IL"/>
           </a:p>
@@ -643,7 +648,7 @@
           <a:p>
             <a:fld id="{85F2A0FB-C061-41D3-B0AC-214264C195BD}" type="datetimeFigureOut">
               <a:rPr lang="en-IL" smtClean="0"/>
-              <a:t>03/03/2025</a:t>
+              <a:t>15/10/2026</a:t>
             </a:fld>
             <a:endParaRPr lang="en-IL"/>
           </a:p>
@@ -813,7 +818,7 @@
           <a:p>
             <a:fld id="{85F2A0FB-C061-41D3-B0AC-214264C195BD}" type="datetimeFigureOut">
               <a:rPr lang="en-IL" smtClean="0"/>
-              <a:t>03/03/2025</a:t>
+              <a:t>15/10/2026</a:t>
             </a:fld>
             <a:endParaRPr lang="en-IL"/>
           </a:p>
@@ -1081,7 +1086,7 @@
           <a:p>
             <a:fld id="{85F2A0FB-C061-41D3-B0AC-214264C195BD}" type="datetimeFigureOut">
               <a:rPr lang="en-IL" smtClean="0"/>
-              <a:t>03/03/2025</a:t>
+              <a:t>15/10/2026</a:t>
             </a:fld>
             <a:endParaRPr lang="en-IL"/>
           </a:p>
@@ -1313,7 +1318,7 @@
           <a:p>
             <a:fld id="{85F2A0FB-C061-41D3-B0AC-214264C195BD}" type="datetimeFigureOut">
               <a:rPr lang="en-IL" smtClean="0"/>
-              <a:t>03/03/2025</a:t>
+              <a:t>15/10/2026</a:t>
             </a:fld>
             <a:endParaRPr lang="en-IL"/>
           </a:p>
@@ -1672,7 +1677,7 @@
           <a:p>
             <a:fld id="{85F2A0FB-C061-41D3-B0AC-214264C195BD}" type="datetimeFigureOut">
               <a:rPr lang="en-IL" smtClean="0"/>
-              <a:t>03/03/2025</a:t>
+              <a:t>15/10/2026</a:t>
             </a:fld>
             <a:endParaRPr lang="en-IL"/>
           </a:p>
@@ -1813,7 +1818,7 @@
           <a:p>
             <a:fld id="{85F2A0FB-C061-41D3-B0AC-214264C195BD}" type="datetimeFigureOut">
               <a:rPr lang="en-IL" smtClean="0"/>
-              <a:t>03/03/2025</a:t>
+              <a:t>15/10/2026</a:t>
             </a:fld>
             <a:endParaRPr lang="en-IL"/>
           </a:p>
@@ -1908,7 +1913,7 @@
           <a:p>
             <a:fld id="{85F2A0FB-C061-41D3-B0AC-214264C195BD}" type="datetimeFigureOut">
               <a:rPr lang="en-IL" smtClean="0"/>
-              <a:t>03/03/2025</a:t>
+              <a:t>15/10/2026</a:t>
             </a:fld>
             <a:endParaRPr lang="en-IL"/>
           </a:p>
@@ -2265,7 +2270,7 @@
           <a:p>
             <a:fld id="{85F2A0FB-C061-41D3-B0AC-214264C195BD}" type="datetimeFigureOut">
               <a:rPr lang="en-IL" smtClean="0"/>
-              <a:t>03/03/2025</a:t>
+              <a:t>15/10/2026</a:t>
             </a:fld>
             <a:endParaRPr lang="en-IL"/>
           </a:p>
@@ -2622,7 +2627,7 @@
           <a:p>
             <a:fld id="{85F2A0FB-C061-41D3-B0AC-214264C195BD}" type="datetimeFigureOut">
               <a:rPr lang="en-IL" smtClean="0"/>
-              <a:t>03/03/2025</a:t>
+              <a:t>15/10/2026</a:t>
             </a:fld>
             <a:endParaRPr lang="en-IL"/>
           </a:p>
@@ -2864,7 +2869,7 @@
           <a:p>
             <a:fld id="{85F2A0FB-C061-41D3-B0AC-214264C195BD}" type="datetimeFigureOut">
               <a:rPr lang="en-IL" smtClean="0"/>
-              <a:t>03/03/2025</a:t>
+              <a:t>15/10/2026</a:t>
             </a:fld>
             <a:endParaRPr lang="en-IL"/>
           </a:p>
@@ -3439,8 +3444,8 @@
           </a:p>
         </p:txBody>
       </p:sp>
-      <mc:AlternateContent xmlns:mc="http://schemas.openxmlformats.org/markup-compatibility/2006">
-        <mc:Choice xmlns:a14="http://schemas.microsoft.com/office/drawing/2010/main" Requires="a14">
+      <mc:AlternateContent xmlns:mc="http://schemas.openxmlformats.org/markup-compatibility/2006" xmlns:a14="http://schemas.microsoft.com/office/drawing/2010/main">
+        <mc:Choice Requires="a14">
           <p:sp>
             <p:nvSpPr>
               <p:cNvPr id="3" name="Content Placeholder 2">
@@ -3506,10 +3511,7 @@
                 </a:pPr>
                 <a14:m>
                   <m:oMathPara xmlns:m="http://schemas.openxmlformats.org/officeDocument/2006/math">
-                    <m:oMathParaPr>
-                      <m:jc m:val="centerGroup"/>
-                    </m:oMathParaPr>
-                    <m:oMath xmlns:m="http://schemas.openxmlformats.org/officeDocument/2006/math">
+                    <m:oMath>
                       <m:r>
                         <a:rPr lang="en-US" i="1" smtClean="0">
                           <a:solidFill>
@@ -3613,10 +3615,7 @@
                 </a:pPr>
                 <a14:m>
                   <m:oMathPara xmlns:m="http://schemas.openxmlformats.org/officeDocument/2006/math">
-                    <m:oMathParaPr>
-                      <m:jc m:val="centerGroup"/>
-                    </m:oMathParaPr>
-                    <m:oMath xmlns:m="http://schemas.openxmlformats.org/officeDocument/2006/math">
+                    <m:oMath>
                       <m:r>
                         <a:rPr lang="en-US" b="0" i="1" smtClean="0">
                           <a:latin typeface="Cambria Math" panose="02040503050406030204" pitchFamily="18" charset="0"/>
@@ -3804,10 +3803,7 @@
                 </a:pPr>
                 <a14:m>
                   <m:oMathPara xmlns:m="http://schemas.openxmlformats.org/officeDocument/2006/math">
-                    <m:oMathParaPr>
-                      <m:jc m:val="centerGroup"/>
-                    </m:oMathParaPr>
-                    <m:oMath xmlns:m="http://schemas.openxmlformats.org/officeDocument/2006/math">
+                    <m:oMath>
                       <m:r>
                         <a:rPr lang="en-US" sz="2500" i="1">
                           <a:latin typeface="Cambria Math" panose="02040503050406030204" pitchFamily="18" charset="0"/>
@@ -3985,7 +3981,7 @@
             </p:txBody>
           </p:sp>
         </mc:Choice>
-        <mc:Fallback>
+        <mc:Fallback xmlns="">
           <p:sp>
             <p:nvSpPr>
               <p:cNvPr id="3" name="Content Placeholder 2">
@@ -4414,8 +4410,8 @@
           </a:p>
         </p:txBody>
       </p:sp>
-      <mc:AlternateContent xmlns:mc="http://schemas.openxmlformats.org/markup-compatibility/2006">
-        <mc:Choice xmlns:a14="http://schemas.microsoft.com/office/drawing/2010/main" Requires="a14">
+      <mc:AlternateContent xmlns:mc="http://schemas.openxmlformats.org/markup-compatibility/2006" xmlns:a14="http://schemas.microsoft.com/office/drawing/2010/main">
+        <mc:Choice Requires="a14">
           <p:sp>
             <p:nvSpPr>
               <p:cNvPr id="3" name="Content Placeholder 2">
@@ -4457,10 +4453,7 @@
                 </a:pPr>
                 <a14:m>
                   <m:oMathPara xmlns:m="http://schemas.openxmlformats.org/officeDocument/2006/math">
-                    <m:oMathParaPr>
-                      <m:jc m:val="centerGroup"/>
-                    </m:oMathParaPr>
-                    <m:oMath xmlns:m="http://schemas.openxmlformats.org/officeDocument/2006/math">
+                    <m:oMath>
                       <m:r>
                         <a:rPr lang="en-US" b="0" i="1" smtClean="0">
                           <a:solidFill>
@@ -4507,16 +4500,7 @@
                               </a:solidFill>
                               <a:latin typeface="Cambria Math" panose="02040503050406030204" pitchFamily="18" charset="0"/>
                             </a:rPr>
-                            <m:t>10</m:t>
-                          </m:r>
-                          <m:r>
-                            <a:rPr lang="en-US" b="0" i="1" smtClean="0">
-                              <a:solidFill>
-                                <a:schemeClr val="tx1"/>
-                              </a:solidFill>
-                              <a:latin typeface="Cambria Math" panose="02040503050406030204" pitchFamily="18" charset="0"/>
-                            </a:rPr>
-                            <m:t>,</m:t>
+                            <m:t>10,</m:t>
                           </m:r>
                           <m:r>
                             <a:rPr lang="en-US" b="0" i="1" smtClean="0">
@@ -4576,10 +4560,7 @@
                 </a:pPr>
                 <a14:m>
                   <m:oMathPara xmlns:m="http://schemas.openxmlformats.org/officeDocument/2006/math">
-                    <m:oMathParaPr>
-                      <m:jc m:val="centerGroup"/>
-                    </m:oMathParaPr>
-                    <m:oMath xmlns:m="http://schemas.openxmlformats.org/officeDocument/2006/math">
+                    <m:oMath>
                       <m:r>
                         <a:rPr lang="en-US" b="0" i="1" smtClean="0">
                           <a:latin typeface="Cambria Math" panose="02040503050406030204" pitchFamily="18" charset="0"/>
@@ -4662,6 +4643,9 @@
                         <m:sSupPr>
                           <m:ctrlPr>
                             <a:rPr lang="en-US" b="0" i="1" smtClean="0">
+                              <a:solidFill>
+                                <a:schemeClr val="tx1"/>
+                              </a:solidFill>
                               <a:latin typeface="Cambria Math" panose="02040503050406030204" pitchFamily="18" charset="0"/>
                             </a:rPr>
                           </m:ctrlPr>
@@ -4708,13 +4692,7 @@
                                 <a:rPr lang="en-US" b="0" i="1" smtClean="0">
                                   <a:latin typeface="Cambria Math" panose="02040503050406030204" pitchFamily="18" charset="0"/>
                                 </a:rPr>
-                                <m:t>1</m:t>
-                              </m:r>
-                              <m:r>
-                                <a:rPr lang="en-US" b="0" i="1" smtClean="0">
-                                  <a:latin typeface="Cambria Math" panose="02040503050406030204" pitchFamily="18" charset="0"/>
-                                </a:rPr>
-                                <m:t>−</m:t>
+                                <m:t>1−</m:t>
                               </m:r>
                               <m:r>
                                 <a:rPr lang="en-US" b="0" i="1" smtClean="0">
@@ -4779,10 +4757,7 @@
                 </a:pPr>
                 <a14:m>
                   <m:oMathPara xmlns:m="http://schemas.openxmlformats.org/officeDocument/2006/math">
-                    <m:oMathParaPr>
-                      <m:jc m:val="centerGroup"/>
-                    </m:oMathParaPr>
-                    <m:oMath xmlns:m="http://schemas.openxmlformats.org/officeDocument/2006/math">
+                    <m:oMath>
                       <m:r>
                         <a:rPr lang="en-US" sz="2500" i="1">
                           <a:latin typeface="Cambria Math" panose="02040503050406030204" pitchFamily="18" charset="0"/>
@@ -4792,7 +4767,7 @@
                       <m:d>
                         <m:dPr>
                           <m:ctrlPr>
-                            <a:rPr lang="en-US" sz="2500" i="1">
+                            <a:rPr lang="en-US" sz="2500" b="0" i="1" smtClean="0">
                               <a:latin typeface="Cambria Math" panose="02040503050406030204" pitchFamily="18" charset="0"/>
                             </a:rPr>
                           </m:ctrlPr>
@@ -4865,6 +4840,9 @@
                         <m:sSupPr>
                           <m:ctrlPr>
                             <a:rPr lang="en-US" sz="2400" b="0" i="1" smtClean="0">
+                              <a:solidFill>
+                                <a:schemeClr val="tx1"/>
+                              </a:solidFill>
                               <a:latin typeface="Cambria Math" panose="02040503050406030204" pitchFamily="18" charset="0"/>
                             </a:rPr>
                           </m:ctrlPr>
@@ -4914,13 +4892,7 @@
                                 <a:rPr lang="en-US" sz="2400" b="0" i="1" smtClean="0">
                                   <a:latin typeface="Cambria Math" panose="02040503050406030204" pitchFamily="18" charset="0"/>
                                 </a:rPr>
-                                <m:t>1</m:t>
-                              </m:r>
-                              <m:r>
-                                <a:rPr lang="en-US" sz="2400" b="0" i="1" smtClean="0">
-                                  <a:latin typeface="Cambria Math" panose="02040503050406030204" pitchFamily="18" charset="0"/>
-                                </a:rPr>
-                                <m:t>−</m:t>
+                                <m:t>1−</m:t>
                               </m:r>
                               <m:r>
                                 <a:rPr lang="en-US" sz="2400" b="0" i="1" smtClean="0">
@@ -4948,13 +4920,7 @@
                             <a:rPr lang="en-US" sz="2400" b="0" i="1" smtClean="0">
                               <a:latin typeface="Cambria Math" panose="02040503050406030204" pitchFamily="18" charset="0"/>
                             </a:rPr>
-                            <m:t>−</m:t>
-                          </m:r>
-                          <m:r>
-                            <a:rPr lang="en-US" sz="2400" b="0" i="1" smtClean="0">
-                              <a:latin typeface="Cambria Math" panose="02040503050406030204" pitchFamily="18" charset="0"/>
-                            </a:rPr>
-                            <m:t>8</m:t>
+                            <m:t>−8</m:t>
                           </m:r>
                         </m:sup>
                       </m:sSup>
@@ -4966,7 +4932,7 @@
             </p:txBody>
           </p:sp>
         </mc:Choice>
-        <mc:Fallback>
+        <mc:Fallback xmlns="">
           <p:sp>
             <p:nvSpPr>
               <p:cNvPr id="3" name="Content Placeholder 2">
@@ -6646,8 +6612,8 @@
           </a:p>
         </p:txBody>
       </p:sp>
-      <mc:AlternateContent xmlns:mc="http://schemas.openxmlformats.org/markup-compatibility/2006">
-        <mc:Choice xmlns:a14="http://schemas.microsoft.com/office/drawing/2010/main" Requires="a14">
+      <mc:AlternateContent xmlns:mc="http://schemas.openxmlformats.org/markup-compatibility/2006" xmlns:a14="http://schemas.microsoft.com/office/drawing/2010/main">
+        <mc:Choice Requires="a14">
           <p:sp>
             <p:nvSpPr>
               <p:cNvPr id="10" name="TextBox 9">
@@ -6676,12 +6642,10 @@
               </a:bodyPr>
               <a:lstStyle/>
               <a:p>
+                <a:pPr/>
                 <a14:m>
                   <m:oMathPara xmlns:m="http://schemas.openxmlformats.org/officeDocument/2006/math">
-                    <m:oMathParaPr>
-                      <m:jc m:val="centerGroup"/>
-                    </m:oMathParaPr>
-                    <m:oMath xmlns:m="http://schemas.openxmlformats.org/officeDocument/2006/math">
+                    <m:oMath>
                       <m:r>
                         <a:rPr lang="en-US" b="0" i="1" smtClean="0">
                           <a:latin typeface="Cambria Math" panose="02040503050406030204" pitchFamily="18" charset="0"/>
@@ -6743,7 +6707,7 @@
             </p:txBody>
           </p:sp>
         </mc:Choice>
-        <mc:Fallback>
+        <mc:Fallback xmlns="">
           <p:sp>
             <p:nvSpPr>
               <p:cNvPr id="10" name="TextBox 9">
@@ -6824,8 +6788,8 @@
           </a:prstGeom>
         </p:spPr>
       </p:pic>
-      <mc:AlternateContent xmlns:mc="http://schemas.openxmlformats.org/markup-compatibility/2006">
-        <mc:Choice xmlns:a14="http://schemas.microsoft.com/office/drawing/2010/main" Requires="a14">
+      <mc:AlternateContent xmlns:mc="http://schemas.openxmlformats.org/markup-compatibility/2006" xmlns:a14="http://schemas.microsoft.com/office/drawing/2010/main">
+        <mc:Choice Requires="a14">
           <p:sp>
             <p:nvSpPr>
               <p:cNvPr id="19" name="TextBox 18">
@@ -6854,12 +6818,10 @@
               </a:bodyPr>
               <a:lstStyle/>
               <a:p>
+                <a:pPr/>
                 <a14:m>
                   <m:oMathPara xmlns:m="http://schemas.openxmlformats.org/officeDocument/2006/math">
-                    <m:oMathParaPr>
-                      <m:jc m:val="centerGroup"/>
-                    </m:oMathParaPr>
-                    <m:oMath xmlns:m="http://schemas.openxmlformats.org/officeDocument/2006/math">
+                    <m:oMath>
                       <m:r>
                         <a:rPr lang="en-US" b="0" i="1" smtClean="0">
                           <a:latin typeface="Cambria Math" panose="02040503050406030204" pitchFamily="18" charset="0"/>
@@ -6936,7 +6898,7 @@
             </p:txBody>
           </p:sp>
         </mc:Choice>
-        <mc:Fallback>
+        <mc:Fallback xmlns="">
           <p:sp>
             <p:nvSpPr>
               <p:cNvPr id="19" name="TextBox 18">
@@ -7046,8 +7008,8 @@
           </a:p>
         </p:txBody>
       </p:sp>
-      <mc:AlternateContent xmlns:mc="http://schemas.openxmlformats.org/markup-compatibility/2006">
-        <mc:Choice xmlns:a14="http://schemas.microsoft.com/office/drawing/2010/main" Requires="a14">
+      <mc:AlternateContent xmlns:mc="http://schemas.openxmlformats.org/markup-compatibility/2006" xmlns:a14="http://schemas.microsoft.com/office/drawing/2010/main">
+        <mc:Choice Requires="a14">
           <p:sp>
             <p:nvSpPr>
               <p:cNvPr id="3" name="Content Placeholder 2">
@@ -7250,7 +7212,7 @@
                           <m:rPr>
                             <m:nor/>
                           </m:rPr>
-                          <a:rPr lang="en-US" dirty="0"/>
+                          <a:rPr lang="en-US" i="0" dirty="0"/>
                           <m:t> </m:t>
                         </m:r>
                       </m:den>
@@ -7594,7 +7556,7 @@
             </p:txBody>
           </p:sp>
         </mc:Choice>
-        <mc:Fallback>
+        <mc:Fallback xmlns="">
           <p:sp>
             <p:nvSpPr>
               <p:cNvPr id="3" name="Content Placeholder 2">
@@ -8281,13 +8243,7 @@
                               <a:rPr lang="en-US" i="1">
                                 <a:latin typeface="Cambria Math" panose="02040503050406030204" pitchFamily="18" charset="0"/>
                               </a:rPr>
-                              <m:t>1</m:t>
-                            </m:r>
-                            <m:r>
-                              <a:rPr lang="en-US" i="1">
-                                <a:latin typeface="Cambria Math" panose="02040503050406030204" pitchFamily="18" charset="0"/>
-                              </a:rPr>
-                              <m:t>−</m:t>
+                              <m:t>1−</m:t>
                             </m:r>
                             <m:r>
                               <a:rPr lang="en-US" b="0" i="1" smtClean="0">
@@ -8346,20 +8302,14 @@
                           <a:rPr lang="en-US" b="0" i="1" smtClean="0">
                             <a:latin typeface="Cambria Math" panose="02040503050406030204" pitchFamily="18" charset="0"/>
                           </a:rPr>
-                          <m:t>−</m:t>
-                        </m:r>
-                        <m:r>
-                          <a:rPr lang="en-US" b="0" i="1" smtClean="0">
-                            <a:latin typeface="Cambria Math" panose="02040503050406030204" pitchFamily="18" charset="0"/>
-                          </a:rPr>
-                          <m:t>1</m:t>
+                          <m:t>−1</m:t>
                         </m:r>
                       </m:sup>
                     </m:sSup>
                     <m:sSup>
                       <m:sSupPr>
                         <m:ctrlPr>
-                          <a:rPr lang="en-US" i="1" smtClean="0">
+                          <a:rPr lang="en-US" i="1">
                             <a:latin typeface="Cambria Math" panose="02040503050406030204" pitchFamily="18" charset="0"/>
                           </a:rPr>
                         </m:ctrlPr>
@@ -8378,13 +8328,7 @@
                               <a:rPr lang="en-US" i="1">
                                 <a:latin typeface="Cambria Math" panose="02040503050406030204" pitchFamily="18" charset="0"/>
                               </a:rPr>
-                              <m:t>1</m:t>
-                            </m:r>
-                            <m:r>
-                              <a:rPr lang="en-US" i="1">
-                                <a:latin typeface="Cambria Math" panose="02040503050406030204" pitchFamily="18" charset="0"/>
-                              </a:rPr>
-                              <m:t>−</m:t>
+                              <m:t>1−</m:t>
                             </m:r>
                             <m:r>
                               <a:rPr lang="en-US" b="0" i="1" smtClean="0">
@@ -8519,13 +8463,7 @@
                               <a:rPr lang="en-US" i="1">
                                 <a:latin typeface="Cambria Math" panose="02040503050406030204" pitchFamily="18" charset="0"/>
                               </a:rPr>
-                              <m:t>1</m:t>
-                            </m:r>
-                            <m:r>
-                              <a:rPr lang="en-US" i="1">
-                                <a:latin typeface="Cambria Math" panose="02040503050406030204" pitchFamily="18" charset="0"/>
-                              </a:rPr>
-                              <m:t>−</m:t>
+                              <m:t>1−</m:t>
                             </m:r>
                             <m:r>
                               <a:rPr lang="en-US" b="0" i="1" smtClean="0">
@@ -8584,20 +8522,14 @@
                           <a:rPr lang="en-US" b="0" i="1" smtClean="0">
                             <a:latin typeface="Cambria Math" panose="02040503050406030204" pitchFamily="18" charset="0"/>
                           </a:rPr>
-                          <m:t>−</m:t>
-                        </m:r>
-                        <m:r>
-                          <a:rPr lang="en-US" b="0" i="1" smtClean="0">
-                            <a:latin typeface="Cambria Math" panose="02040503050406030204" pitchFamily="18" charset="0"/>
-                          </a:rPr>
-                          <m:t>1</m:t>
+                          <m:t>−1</m:t>
                         </m:r>
                       </m:sup>
                     </m:sSup>
                     <m:sSup>
                       <m:sSupPr>
                         <m:ctrlPr>
-                          <a:rPr lang="en-US" i="1" smtClean="0">
+                          <a:rPr lang="en-US" i="1">
                             <a:latin typeface="Cambria Math" panose="02040503050406030204" pitchFamily="18" charset="0"/>
                           </a:rPr>
                         </m:ctrlPr>
@@ -8616,13 +8548,7 @@
                               <a:rPr lang="en-US" i="1">
                                 <a:latin typeface="Cambria Math" panose="02040503050406030204" pitchFamily="18" charset="0"/>
                               </a:rPr>
-                              <m:t>1</m:t>
-                            </m:r>
-                            <m:r>
-                              <a:rPr lang="en-US" i="1">
-                                <a:latin typeface="Cambria Math" panose="02040503050406030204" pitchFamily="18" charset="0"/>
-                              </a:rPr>
-                              <m:t>−</m:t>
+                              <m:t>1−</m:t>
                             </m:r>
                             <m:r>
                               <a:rPr lang="en-US" b="0" i="1" smtClean="0">
@@ -8749,13 +8675,7 @@
                           <a:rPr lang="en-US" b="0" i="1" smtClean="0">
                             <a:latin typeface="Cambria Math" panose="02040503050406030204" pitchFamily="18" charset="0"/>
                           </a:rPr>
-                          <m:t>−</m:t>
-                        </m:r>
-                        <m:r>
-                          <a:rPr lang="en-US" b="0" i="1" smtClean="0">
-                            <a:latin typeface="Cambria Math" panose="02040503050406030204" pitchFamily="18" charset="0"/>
-                          </a:rPr>
-                          <m:t>1</m:t>
+                          <m:t>−1</m:t>
                         </m:r>
                       </m:sup>
                     </m:sSup>
@@ -8781,13 +8701,7 @@
                               <a:rPr lang="en-US" i="1">
                                 <a:latin typeface="Cambria Math" panose="02040503050406030204" pitchFamily="18" charset="0"/>
                               </a:rPr>
-                              <m:t>1</m:t>
-                            </m:r>
-                            <m:r>
-                              <a:rPr lang="en-US" i="1">
-                                <a:latin typeface="Cambria Math" panose="02040503050406030204" pitchFamily="18" charset="0"/>
-                              </a:rPr>
-                              <m:t>−</m:t>
+                              <m:t>1−</m:t>
                             </m:r>
                             <m:r>
                               <a:rPr lang="en-US" b="0" i="1" smtClean="0">
@@ -8833,13 +8747,7 @@
                           <a:rPr lang="en-US" b="0" i="1" smtClean="0">
                             <a:latin typeface="Cambria Math" panose="02040503050406030204" pitchFamily="18" charset="0"/>
                           </a:rPr>
-                          <m:t>−</m:t>
-                        </m:r>
-                        <m:r>
-                          <a:rPr lang="en-US" b="0" i="1" smtClean="0">
-                            <a:latin typeface="Cambria Math" panose="02040503050406030204" pitchFamily="18" charset="0"/>
-                          </a:rPr>
-                          <m:t>1</m:t>
+                          <m:t>−1</m:t>
                         </m:r>
                       </m:sup>
                     </m:sSup>
@@ -8921,13 +8829,7 @@
                               <a:rPr lang="en-US" b="0" i="1" smtClean="0">
                                 <a:latin typeface="Cambria Math" panose="02040503050406030204" pitchFamily="18" charset="0"/>
                               </a:rPr>
-                              <m:t>−</m:t>
-                            </m:r>
-                            <m:r>
-                              <a:rPr lang="en-US" b="0" i="1" smtClean="0">
-                                <a:latin typeface="Cambria Math" panose="02040503050406030204" pitchFamily="18" charset="0"/>
-                              </a:rPr>
-                              <m:t>1</m:t>
+                              <m:t>−1</m:t>
                             </m:r>
                           </m:sup>
                         </m:sSup>
@@ -8953,13 +8855,7 @@
                                   <a:rPr lang="en-US" i="1">
                                     <a:latin typeface="Cambria Math" panose="02040503050406030204" pitchFamily="18" charset="0"/>
                                   </a:rPr>
-                                  <m:t>1</m:t>
-                                </m:r>
-                                <m:r>
-                                  <a:rPr lang="en-US" i="1">
-                                    <a:latin typeface="Cambria Math" panose="02040503050406030204" pitchFamily="18" charset="0"/>
-                                  </a:rPr>
-                                  <m:t>−</m:t>
+                                  <m:t>1−</m:t>
                                 </m:r>
                                 <m:r>
                                   <a:rPr lang="en-US" b="0" i="1" smtClean="0">
@@ -8981,13 +8877,7 @@
                               <a:rPr lang="en-US" b="0" i="1" smtClean="0">
                                 <a:latin typeface="Cambria Math" panose="02040503050406030204" pitchFamily="18" charset="0"/>
                               </a:rPr>
-                              <m:t>−</m:t>
-                            </m:r>
-                            <m:r>
-                              <a:rPr lang="en-US" b="0" i="1" smtClean="0">
-                                <a:latin typeface="Cambria Math" panose="02040503050406030204" pitchFamily="18" charset="0"/>
-                              </a:rPr>
-                              <m:t>1</m:t>
+                              <m:t>−1</m:t>
                             </m:r>
                           </m:sup>
                         </m:sSup>
@@ -9146,7 +9036,7 @@
                     <m:f>
                       <m:fPr>
                         <m:ctrlPr>
-                          <a:rPr lang="en-US" b="0" i="0" smtClean="0">
+                          <a:rPr lang="en-US" b="0" i="1" smtClean="0">
                             <a:latin typeface="Cambria Math" panose="02040503050406030204" pitchFamily="18" charset="0"/>
                           </a:rPr>
                         </m:ctrlPr>
@@ -9191,13 +9081,7 @@
                               <a:rPr lang="en-US" b="0" i="1" smtClean="0">
                                 <a:latin typeface="Cambria Math" panose="02040503050406030204" pitchFamily="18" charset="0"/>
                               </a:rPr>
-                              <m:t>−</m:t>
-                            </m:r>
-                            <m:r>
-                              <a:rPr lang="en-US" b="0" i="1" smtClean="0">
-                                <a:latin typeface="Cambria Math" panose="02040503050406030204" pitchFamily="18" charset="0"/>
-                              </a:rPr>
-                              <m:t>1</m:t>
+                              <m:t>−1</m:t>
                             </m:r>
                           </m:sup>
                         </m:sSup>
@@ -9223,13 +9107,7 @@
                                   <a:rPr lang="en-US" i="1">
                                     <a:latin typeface="Cambria Math" panose="02040503050406030204" pitchFamily="18" charset="0"/>
                                   </a:rPr>
-                                  <m:t>1</m:t>
-                                </m:r>
-                                <m:r>
-                                  <a:rPr lang="en-US" i="1">
-                                    <a:latin typeface="Cambria Math" panose="02040503050406030204" pitchFamily="18" charset="0"/>
-                                  </a:rPr>
-                                  <m:t>−</m:t>
+                                  <m:t>1−</m:t>
                                 </m:r>
                                 <m:r>
                                   <a:rPr lang="en-US" b="0" i="1" smtClean="0">
@@ -9275,13 +9153,7 @@
                               <a:rPr lang="en-US" b="0" i="1" smtClean="0">
                                 <a:latin typeface="Cambria Math" panose="02040503050406030204" pitchFamily="18" charset="0"/>
                               </a:rPr>
-                              <m:t>−</m:t>
-                            </m:r>
-                            <m:r>
-                              <a:rPr lang="en-US" b="0" i="1" smtClean="0">
-                                <a:latin typeface="Cambria Math" panose="02040503050406030204" pitchFamily="18" charset="0"/>
-                              </a:rPr>
-                              <m:t>1</m:t>
+                              <m:t>−1</m:t>
                             </m:r>
                           </m:sup>
                         </m:sSup>
@@ -9303,7 +9175,7 @@
                           <a:rPr lang="en-US" b="0" i="1" smtClean="0">
                             <a:latin typeface="Cambria Math" panose="02040503050406030204" pitchFamily="18" charset="0"/>
                           </a:rPr>
-                          <m:t>𝑛</m:t>
+                          <m:t>𝑦</m:t>
                         </m:r>
                         <m:r>
                           <a:rPr lang="en-US" b="0" i="1" smtClean="0">
@@ -10195,13 +10067,7 @@
                               <a:rPr lang="en-US" sz="2000" b="0" i="1" smtClean="0">
                                 <a:latin typeface="Cambria Math" panose="02040503050406030204" pitchFamily="18" charset="0"/>
                               </a:rPr>
-                              <m:t>−</m:t>
-                            </m:r>
-                            <m:r>
-                              <a:rPr lang="en-US" sz="2000" b="0" i="1" smtClean="0">
-                                <a:latin typeface="Cambria Math" panose="02040503050406030204" pitchFamily="18" charset="0"/>
-                              </a:rPr>
-                              <m:t>1</m:t>
+                              <m:t>−1</m:t>
                             </m:r>
                           </m:sup>
                         </m:sSup>
@@ -10227,13 +10093,7 @@
                                   <a:rPr lang="en-US" sz="2000" i="1">
                                     <a:latin typeface="Cambria Math" panose="02040503050406030204" pitchFamily="18" charset="0"/>
                                   </a:rPr>
-                                  <m:t>1</m:t>
-                                </m:r>
-                                <m:r>
-                                  <a:rPr lang="en-US" sz="2000" i="1">
-                                    <a:latin typeface="Cambria Math" panose="02040503050406030204" pitchFamily="18" charset="0"/>
-                                  </a:rPr>
-                                  <m:t>−</m:t>
+                                  <m:t>1−</m:t>
                                 </m:r>
                                 <m:r>
                                   <a:rPr lang="en-US" sz="2000" b="0" i="1" smtClean="0">
@@ -10279,13 +10139,7 @@
                               <a:rPr lang="en-US" sz="2000" b="0" i="1" smtClean="0">
                                 <a:latin typeface="Cambria Math" panose="02040503050406030204" pitchFamily="18" charset="0"/>
                               </a:rPr>
-                              <m:t>−</m:t>
-                            </m:r>
-                            <m:r>
-                              <a:rPr lang="en-US" sz="2000" b="0" i="1" smtClean="0">
-                                <a:latin typeface="Cambria Math" panose="02040503050406030204" pitchFamily="18" charset="0"/>
-                              </a:rPr>
-                              <m:t>1</m:t>
+                              <m:t>−1</m:t>
                             </m:r>
                           </m:sup>
                         </m:sSup>
@@ -10467,18 +10321,6 @@
                         <a:latin typeface="Cambria Math" panose="02040503050406030204" pitchFamily="18" charset="0"/>
                       </a:rPr>
                       <m:t>𝛽</m:t>
-                    </m:r>
-                    <m:r>
-                      <a:rPr lang="en-US" sz="2000" b="0" i="1" smtClean="0">
-                        <a:latin typeface="Cambria Math" panose="02040503050406030204" pitchFamily="18" charset="0"/>
-                      </a:rPr>
-                      <m:t>−</m:t>
-                    </m:r>
-                    <m:r>
-                      <a:rPr lang="en-US" sz="2000" b="0" i="1" smtClean="0">
-                        <a:latin typeface="Cambria Math" panose="02040503050406030204" pitchFamily="18" charset="0"/>
-                      </a:rPr>
-                      <m:t>1</m:t>
                     </m:r>
                     <m:r>
                       <a:rPr lang="en-US" sz="2000" b="0" i="1" smtClean="0">
@@ -14353,8 +14195,8 @@
           </a:p>
         </p:txBody>
       </p:sp>
-      <mc:AlternateContent xmlns:mc="http://schemas.openxmlformats.org/markup-compatibility/2006">
-        <mc:Choice xmlns:a14="http://schemas.microsoft.com/office/drawing/2010/main" Requires="a14">
+      <mc:AlternateContent xmlns:mc="http://schemas.openxmlformats.org/markup-compatibility/2006" xmlns:a14="http://schemas.microsoft.com/office/drawing/2010/main">
+        <mc:Choice Requires="a14">
           <p:sp>
             <p:nvSpPr>
               <p:cNvPr id="3" name="Content Placeholder 2">
@@ -14570,7 +14412,7 @@
             </p:txBody>
           </p:sp>
         </mc:Choice>
-        <mc:Fallback>
+        <mc:Fallback xmlns="">
           <p:sp>
             <p:nvSpPr>
               <p:cNvPr id="3" name="Content Placeholder 2">
@@ -16141,8 +15983,8 @@
           </a:p>
         </p:txBody>
       </p:sp>
-      <mc:AlternateContent xmlns:mc="http://schemas.openxmlformats.org/markup-compatibility/2006">
-        <mc:Choice xmlns:a14="http://schemas.microsoft.com/office/drawing/2010/main" Requires="a14">
+      <mc:AlternateContent xmlns:mc="http://schemas.openxmlformats.org/markup-compatibility/2006" xmlns:a14="http://schemas.microsoft.com/office/drawing/2010/main">
+        <mc:Choice Requires="a14">
           <p:sp>
             <p:nvSpPr>
               <p:cNvPr id="3" name="Content Placeholder 2">
@@ -16438,7 +16280,7 @@
                     <m:d>
                       <m:dPr>
                         <m:ctrlPr>
-                          <a:rPr lang="en-US" b="0" i="0" smtClean="0">
+                          <a:rPr lang="en-US" b="0" i="1" smtClean="0">
                             <a:latin typeface="Cambria Math" panose="02040503050406030204" pitchFamily="18" charset="0"/>
                           </a:rPr>
                         </m:ctrlPr>
@@ -16862,13 +16704,7 @@
                           <a:rPr lang="en-US" b="0" i="0" smtClean="0">
                             <a:latin typeface="Cambria Math" panose="02040503050406030204" pitchFamily="18" charset="0"/>
                           </a:rPr>
-                          <m:t>0.5∗</m:t>
-                        </m:r>
-                        <m:r>
-                          <a:rPr lang="en-US" b="0" i="0" smtClean="0">
-                            <a:latin typeface="Cambria Math" panose="02040503050406030204" pitchFamily="18" charset="0"/>
-                          </a:rPr>
-                          <m:t>0.5</m:t>
+                          <m:t>0.5∗0.5</m:t>
                         </m:r>
                       </m:num>
                       <m:den>
@@ -16943,7 +16779,7 @@
             </p:txBody>
           </p:sp>
         </mc:Choice>
-        <mc:Fallback>
+        <mc:Fallback xmlns="">
           <p:sp>
             <p:nvSpPr>
               <p:cNvPr id="3" name="Content Placeholder 2">
@@ -17402,8 +17238,8 @@
           </a:p>
         </p:txBody>
       </p:sp>
-      <mc:AlternateContent xmlns:mc="http://schemas.openxmlformats.org/markup-compatibility/2006">
-        <mc:Choice xmlns:a14="http://schemas.microsoft.com/office/drawing/2010/main" Requires="a14">
+      <mc:AlternateContent xmlns:mc="http://schemas.openxmlformats.org/markup-compatibility/2006" xmlns:a14="http://schemas.microsoft.com/office/drawing/2010/main">
+        <mc:Choice Requires="a14">
           <p:sp>
             <p:nvSpPr>
               <p:cNvPr id="14" name="Rectangle 13">
@@ -17448,10 +17284,7 @@
                 <a:pPr algn="ctr"/>
                 <a14:m>
                   <m:oMathPara xmlns:m="http://schemas.openxmlformats.org/officeDocument/2006/math">
-                    <m:oMathParaPr>
-                      <m:jc m:val="centerGroup"/>
-                    </m:oMathParaPr>
-                    <m:oMath xmlns:m="http://schemas.openxmlformats.org/officeDocument/2006/math">
+                    <m:oMath>
                       <m:r>
                         <m:rPr>
                           <m:sty m:val="p"/>
@@ -17469,7 +17302,7 @@
             </p:txBody>
           </p:sp>
         </mc:Choice>
-        <mc:Fallback>
+        <mc:Fallback xmlns="">
           <p:sp>
             <p:nvSpPr>
               <p:cNvPr id="14" name="Rectangle 13">
@@ -17514,8 +17347,8 @@
           </p:sp>
         </mc:Fallback>
       </mc:AlternateContent>
-      <mc:AlternateContent xmlns:mc="http://schemas.openxmlformats.org/markup-compatibility/2006">
-        <mc:Choice xmlns:a14="http://schemas.microsoft.com/office/drawing/2010/main" Requires="a14">
+      <mc:AlternateContent xmlns:mc="http://schemas.openxmlformats.org/markup-compatibility/2006" xmlns:a14="http://schemas.microsoft.com/office/drawing/2010/main">
+        <mc:Choice Requires="a14">
           <p:sp>
             <p:nvSpPr>
               <p:cNvPr id="15" name="Rectangle 14">
@@ -17560,10 +17393,7 @@
                 <a:pPr algn="ctr"/>
                 <a14:m>
                   <m:oMathPara xmlns:m="http://schemas.openxmlformats.org/officeDocument/2006/math">
-                    <m:oMathParaPr>
-                      <m:jc m:val="centerGroup"/>
-                    </m:oMathParaPr>
-                    <m:oMath xmlns:m="http://schemas.openxmlformats.org/officeDocument/2006/math">
+                    <m:oMath>
                       <m:sSup>
                         <m:sSupPr>
                           <m:ctrlPr>
@@ -17603,7 +17433,7 @@
             </p:txBody>
           </p:sp>
         </mc:Choice>
-        <mc:Fallback>
+        <mc:Fallback xmlns="">
           <p:sp>
             <p:nvSpPr>
               <p:cNvPr id="15" name="Rectangle 14">
@@ -18308,8 +18138,8 @@
           </a:p>
         </p:txBody>
       </p:sp>
-      <mc:AlternateContent xmlns:mc="http://schemas.openxmlformats.org/markup-compatibility/2006">
-        <mc:Choice xmlns:a14="http://schemas.microsoft.com/office/drawing/2010/main" Requires="a14">
+      <mc:AlternateContent xmlns:mc="http://schemas.openxmlformats.org/markup-compatibility/2006" xmlns:a14="http://schemas.microsoft.com/office/drawing/2010/main">
+        <mc:Choice Requires="a14">
           <p:sp>
             <p:nvSpPr>
               <p:cNvPr id="3" name="Content Placeholder 2">
@@ -18562,7 +18392,7 @@
                           <m:rPr>
                             <m:nor/>
                           </m:rPr>
-                          <a:rPr lang="en-US" dirty="0"/>
+                          <a:rPr lang="en-US" i="0" dirty="0"/>
                           <m:t> </m:t>
                         </m:r>
                       </m:den>
@@ -18728,7 +18558,7 @@
             </p:txBody>
           </p:sp>
         </mc:Choice>
-        <mc:Fallback>
+        <mc:Fallback xmlns="">
           <p:sp>
             <p:nvSpPr>
               <p:cNvPr id="3" name="Content Placeholder 2">
@@ -19345,8 +19175,8 @@
           </a:p>
         </p:txBody>
       </p:sp>
-      <mc:AlternateContent xmlns:mc="http://schemas.openxmlformats.org/markup-compatibility/2006">
-        <mc:Choice xmlns:a14="http://schemas.microsoft.com/office/drawing/2010/main" Requires="a14">
+      <mc:AlternateContent xmlns:mc="http://schemas.openxmlformats.org/markup-compatibility/2006" xmlns:a14="http://schemas.microsoft.com/office/drawing/2010/main">
+        <mc:Choice Requires="a14">
           <p:sp>
             <p:nvSpPr>
               <p:cNvPr id="3" name="Content Placeholder 2">
@@ -19436,10 +19266,7 @@
                 </a:pPr>
                 <a14:m>
                   <m:oMathPara xmlns:m="http://schemas.openxmlformats.org/officeDocument/2006/math">
-                    <m:oMathParaPr>
-                      <m:jc m:val="centerGroup"/>
-                    </m:oMathParaPr>
-                    <m:oMath xmlns:m="http://schemas.openxmlformats.org/officeDocument/2006/math">
+                    <m:oMath>
                       <m:r>
                         <a:rPr lang="en-US" b="0" i="1" smtClean="0">
                           <a:latin typeface="Cambria Math" panose="02040503050406030204" pitchFamily="18" charset="0"/>
@@ -19540,7 +19367,7 @@
             </p:txBody>
           </p:sp>
         </mc:Choice>
-        <mc:Fallback>
+        <mc:Fallback xmlns="">
           <p:sp>
             <p:nvSpPr>
               <p:cNvPr id="3" name="Content Placeholder 2">
@@ -20042,8 +19869,8 @@
           </a:p>
         </p:txBody>
       </p:sp>
-      <mc:AlternateContent xmlns:mc="http://schemas.openxmlformats.org/markup-compatibility/2006">
-        <mc:Choice xmlns:a14="http://schemas.microsoft.com/office/drawing/2010/main" Requires="a14">
+      <mc:AlternateContent xmlns:mc="http://schemas.openxmlformats.org/markup-compatibility/2006" xmlns:a14="http://schemas.microsoft.com/office/drawing/2010/main">
+        <mc:Choice Requires="a14">
           <p:sp>
             <p:nvSpPr>
               <p:cNvPr id="3" name="Content Placeholder 2">
@@ -20171,16 +19998,7 @@
                                 </a:solidFill>
                                 <a:latin typeface="Cambria Math" panose="02040503050406030204" pitchFamily="18" charset="0"/>
                               </a:rPr>
-                              <m:t>1</m:t>
-                            </m:r>
-                            <m:r>
-                              <a:rPr lang="en-US" b="0" i="1" smtClean="0">
-                                <a:solidFill>
-                                  <a:schemeClr val="tx1"/>
-                                </a:solidFill>
-                                <a:latin typeface="Cambria Math" panose="02040503050406030204" pitchFamily="18" charset="0"/>
-                              </a:rPr>
-                              <m:t>−</m:t>
+                              <m:t>1−</m:t>
                             </m:r>
                             <m:r>
                               <a:rPr lang="en-US" b="0" i="1" smtClean="0">
@@ -20211,16 +20029,7 @@
                             </a:solidFill>
                             <a:latin typeface="Cambria Math" panose="02040503050406030204" pitchFamily="18" charset="0"/>
                           </a:rPr>
-                          <m:t>−</m:t>
-                        </m:r>
-                        <m:r>
-                          <a:rPr lang="en-US" b="0" i="1" smtClean="0">
-                            <a:solidFill>
-                              <a:schemeClr val="tx1"/>
-                            </a:solidFill>
-                            <a:latin typeface="Cambria Math" panose="02040503050406030204" pitchFamily="18" charset="0"/>
-                          </a:rPr>
-                          <m:t>1</m:t>
+                          <m:t>−1</m:t>
                         </m:r>
                       </m:sup>
                     </m:sSup>
@@ -20378,10 +20187,7 @@
                 </a:pPr>
                 <a14:m>
                   <m:oMathPara xmlns:m="http://schemas.openxmlformats.org/officeDocument/2006/math">
-                    <m:oMathParaPr>
-                      <m:jc m:val="centerGroup"/>
-                    </m:oMathParaPr>
-                    <m:oMath xmlns:m="http://schemas.openxmlformats.org/officeDocument/2006/math">
+                    <m:oMath>
                       <m:r>
                         <a:rPr lang="en-US" b="0" i="1" smtClean="0">
                           <a:solidFill>
@@ -20630,16 +20436,7 @@
                                       </a:solidFill>
                                       <a:latin typeface="Cambria Math" panose="02040503050406030204" pitchFamily="18" charset="0"/>
                                     </a:rPr>
-                                    <m:t>1</m:t>
-                                  </m:r>
-                                  <m:r>
-                                    <a:rPr lang="en-US" b="0" i="1" smtClean="0">
-                                      <a:solidFill>
-                                        <a:schemeClr val="tx1"/>
-                                      </a:solidFill>
-                                      <a:latin typeface="Cambria Math" panose="02040503050406030204" pitchFamily="18" charset="0"/>
-                                    </a:rPr>
-                                    <m:t>−</m:t>
+                                    <m:t>1−</m:t>
                                   </m:r>
                                   <m:r>
                                     <a:rPr lang="en-US" b="0" i="1" smtClean="0">
@@ -20695,16 +20492,7 @@
                                   </a:solidFill>
                                   <a:latin typeface="Cambria Math" panose="02040503050406030204" pitchFamily="18" charset="0"/>
                                 </a:rPr>
-                                <m:t>−</m:t>
-                              </m:r>
-                              <m:r>
-                                <a:rPr lang="en-US" b="0" i="1" smtClean="0">
-                                  <a:solidFill>
-                                    <a:schemeClr val="tx1"/>
-                                  </a:solidFill>
-                                  <a:latin typeface="Cambria Math" panose="02040503050406030204" pitchFamily="18" charset="0"/>
-                                </a:rPr>
-                                <m:t>1</m:t>
+                                <m:t>−1</m:t>
                               </m:r>
                             </m:sup>
                           </m:sSup>
@@ -20772,17 +20560,7 @@
                                       <a:latin typeface="Cambria Math" panose="02040503050406030204" pitchFamily="18" charset="0"/>
                                       <a:ea typeface="Cambria Math" panose="02040503050406030204" pitchFamily="18" charset="0"/>
                                     </a:rPr>
-                                    <m:t>1</m:t>
-                                  </m:r>
-                                  <m:r>
-                                    <a:rPr lang="en-US" b="0" i="1" smtClean="0">
-                                      <a:solidFill>
-                                        <a:schemeClr val="tx1"/>
-                                      </a:solidFill>
-                                      <a:latin typeface="Cambria Math" panose="02040503050406030204" pitchFamily="18" charset="0"/>
-                                      <a:ea typeface="Cambria Math" panose="02040503050406030204" pitchFamily="18" charset="0"/>
-                                    </a:rPr>
-                                    <m:t>−</m:t>
+                                    <m:t>1−</m:t>
                                   </m:r>
                                   <m:r>
                                     <a:rPr lang="en-US" b="0" i="1" smtClean="0">
@@ -20843,17 +20621,7 @@
                                   <a:latin typeface="Cambria Math" panose="02040503050406030204" pitchFamily="18" charset="0"/>
                                   <a:ea typeface="Cambria Math" panose="02040503050406030204" pitchFamily="18" charset="0"/>
                                 </a:rPr>
-                                <m:t>−</m:t>
-                              </m:r>
-                              <m:r>
-                                <a:rPr lang="en-US" b="0" i="1" smtClean="0">
-                                  <a:solidFill>
-                                    <a:schemeClr val="tx1"/>
-                                  </a:solidFill>
-                                  <a:latin typeface="Cambria Math" panose="02040503050406030204" pitchFamily="18" charset="0"/>
-                                  <a:ea typeface="Cambria Math" panose="02040503050406030204" pitchFamily="18" charset="0"/>
-                                </a:rPr>
-                                <m:t>1</m:t>
+                                <m:t>−1</m:t>
                               </m:r>
                             </m:sup>
                           </m:sSup>
@@ -20923,17 +20691,7 @@
                                   <a:latin typeface="Cambria Math" panose="02040503050406030204" pitchFamily="18" charset="0"/>
                                   <a:ea typeface="Cambria Math" panose="02040503050406030204" pitchFamily="18" charset="0"/>
                                 </a:rPr>
-                                <m:t>1</m:t>
-                              </m:r>
-                              <m:r>
-                                <a:rPr lang="en-US" i="1">
-                                  <a:solidFill>
-                                    <a:schemeClr val="tx1"/>
-                                  </a:solidFill>
-                                  <a:latin typeface="Cambria Math" panose="02040503050406030204" pitchFamily="18" charset="0"/>
-                                  <a:ea typeface="Cambria Math" panose="02040503050406030204" pitchFamily="18" charset="0"/>
-                                </a:rPr>
-                                <m:t>−</m:t>
+                                <m:t>1−</m:t>
                               </m:r>
                               <m:r>
                                 <a:rPr lang="en-US" i="1">
@@ -20994,17 +20752,7 @@
                               <a:latin typeface="Cambria Math" panose="02040503050406030204" pitchFamily="18" charset="0"/>
                               <a:ea typeface="Cambria Math" panose="02040503050406030204" pitchFamily="18" charset="0"/>
                             </a:rPr>
-                            <m:t>−</m:t>
-                          </m:r>
-                          <m:r>
-                            <a:rPr lang="en-US" i="1">
-                              <a:solidFill>
-                                <a:schemeClr val="tx1"/>
-                              </a:solidFill>
-                              <a:latin typeface="Cambria Math" panose="02040503050406030204" pitchFamily="18" charset="0"/>
-                              <a:ea typeface="Cambria Math" panose="02040503050406030204" pitchFamily="18" charset="0"/>
-                            </a:rPr>
-                            <m:t>1</m:t>
+                            <m:t>−1</m:t>
                           </m:r>
                         </m:sup>
                       </m:sSup>
@@ -21044,10 +20792,7 @@
                 </a:pPr>
                 <a14:m>
                   <m:oMathPara xmlns:m="http://schemas.openxmlformats.org/officeDocument/2006/math">
-                    <m:oMathParaPr>
-                      <m:jc m:val="centerGroup"/>
-                    </m:oMathParaPr>
-                    <m:oMath xmlns:m="http://schemas.openxmlformats.org/officeDocument/2006/math">
+                    <m:oMath>
                       <m:r>
                         <a:rPr lang="he-IL" b="0" i="1" smtClean="0">
                           <a:solidFill>
@@ -21123,14 +20868,7 @@
                                   <a:latin typeface="Cambria Math" panose="02040503050406030204" pitchFamily="18" charset="0"/>
                                   <a:ea typeface="Cambria Math" panose="02040503050406030204" pitchFamily="18" charset="0"/>
                                 </a:rPr>
-                                <m:t>1</m:t>
-                              </m:r>
-                              <m:r>
-                                <a:rPr lang="en-US" b="0" i="1" smtClean="0">
-                                  <a:latin typeface="Cambria Math" panose="02040503050406030204" pitchFamily="18" charset="0"/>
-                                  <a:ea typeface="Cambria Math" panose="02040503050406030204" pitchFamily="18" charset="0"/>
-                                </a:rPr>
-                                <m:t>−</m:t>
+                                <m:t>1−</m:t>
                               </m:r>
                               <m:r>
                                 <a:rPr lang="en-US" b="0" i="1" smtClean="0">
@@ -21176,21 +20914,7 @@
                               <a:latin typeface="Cambria Math" panose="02040503050406030204" pitchFamily="18" charset="0"/>
                               <a:ea typeface="Cambria Math" panose="02040503050406030204" pitchFamily="18" charset="0"/>
                             </a:rPr>
-                            <m:t>−</m:t>
-                          </m:r>
-                          <m:r>
-                            <a:rPr lang="en-US" b="0" i="1" smtClean="0">
-                              <a:latin typeface="Cambria Math" panose="02040503050406030204" pitchFamily="18" charset="0"/>
-                              <a:ea typeface="Cambria Math" panose="02040503050406030204" pitchFamily="18" charset="0"/>
-                            </a:rPr>
-                            <m:t>1</m:t>
-                          </m:r>
-                          <m:r>
-                            <a:rPr lang="en-US" b="0" i="1" smtClean="0">
-                              <a:latin typeface="Cambria Math" panose="02040503050406030204" pitchFamily="18" charset="0"/>
-                              <a:ea typeface="Cambria Math" panose="02040503050406030204" pitchFamily="18" charset="0"/>
-                            </a:rPr>
-                            <m:t>+</m:t>
+                            <m:t>−1+</m:t>
                           </m:r>
                           <m:sSub>
                             <m:sSubPr>
@@ -21225,21 +20949,7 @@
                               <a:latin typeface="Cambria Math" panose="02040503050406030204" pitchFamily="18" charset="0"/>
                               <a:ea typeface="Cambria Math" panose="02040503050406030204" pitchFamily="18" charset="0"/>
                             </a:rPr>
-                            <m:t>−</m:t>
-                          </m:r>
-                          <m:r>
-                            <a:rPr lang="en-US" b="0" i="1" smtClean="0">
-                              <a:latin typeface="Cambria Math" panose="02040503050406030204" pitchFamily="18" charset="0"/>
-                              <a:ea typeface="Cambria Math" panose="02040503050406030204" pitchFamily="18" charset="0"/>
-                            </a:rPr>
-                            <m:t>1</m:t>
-                          </m:r>
-                          <m:r>
-                            <a:rPr lang="en-US" b="0" i="1" smtClean="0">
-                              <a:latin typeface="Cambria Math" panose="02040503050406030204" pitchFamily="18" charset="0"/>
-                              <a:ea typeface="Cambria Math" panose="02040503050406030204" pitchFamily="18" charset="0"/>
-                            </a:rPr>
-                            <m:t>+</m:t>
+                            <m:t>−1+</m:t>
                           </m:r>
                           <m:sSub>
                             <m:sSubPr>
@@ -21274,21 +20984,7 @@
                               <a:latin typeface="Cambria Math" panose="02040503050406030204" pitchFamily="18" charset="0"/>
                               <a:ea typeface="Cambria Math" panose="02040503050406030204" pitchFamily="18" charset="0"/>
                             </a:rPr>
-                            <m:t>−</m:t>
-                          </m:r>
-                          <m:r>
-                            <a:rPr lang="en-US" b="0" i="1" smtClean="0">
-                              <a:latin typeface="Cambria Math" panose="02040503050406030204" pitchFamily="18" charset="0"/>
-                              <a:ea typeface="Cambria Math" panose="02040503050406030204" pitchFamily="18" charset="0"/>
-                            </a:rPr>
-                            <m:t>1</m:t>
-                          </m:r>
-                          <m:r>
-                            <a:rPr lang="en-US" b="0" i="1" smtClean="0">
-                              <a:latin typeface="Cambria Math" panose="02040503050406030204" pitchFamily="18" charset="0"/>
-                              <a:ea typeface="Cambria Math" panose="02040503050406030204" pitchFamily="18" charset="0"/>
-                            </a:rPr>
-                            <m:t>+…+</m:t>
+                            <m:t>−1+…+</m:t>
                           </m:r>
                           <m:sSub>
                             <m:sSubPr>
@@ -21323,14 +21019,7 @@
                               <a:latin typeface="Cambria Math" panose="02040503050406030204" pitchFamily="18" charset="0"/>
                               <a:ea typeface="Cambria Math" panose="02040503050406030204" pitchFamily="18" charset="0"/>
                             </a:rPr>
-                            <m:t>−</m:t>
-                          </m:r>
-                          <m:r>
-                            <a:rPr lang="en-US" b="0" i="1" smtClean="0">
-                              <a:latin typeface="Cambria Math" panose="02040503050406030204" pitchFamily="18" charset="0"/>
-                              <a:ea typeface="Cambria Math" panose="02040503050406030204" pitchFamily="18" charset="0"/>
-                            </a:rPr>
-                            <m:t>1</m:t>
+                            <m:t>−1</m:t>
                           </m:r>
                         </m:sup>
                       </m:sSup>
@@ -21401,14 +21090,7 @@
                                   <a:latin typeface="Cambria Math" panose="02040503050406030204" pitchFamily="18" charset="0"/>
                                   <a:ea typeface="Cambria Math" panose="02040503050406030204" pitchFamily="18" charset="0"/>
                                 </a:rPr>
-                                <m:t>1</m:t>
-                              </m:r>
-                              <m:r>
-                                <a:rPr lang="en-US" b="0" i="1" smtClean="0">
-                                  <a:latin typeface="Cambria Math" panose="02040503050406030204" pitchFamily="18" charset="0"/>
-                                  <a:ea typeface="Cambria Math" panose="02040503050406030204" pitchFamily="18" charset="0"/>
-                                </a:rPr>
-                                <m:t>−</m:t>
+                                <m:t>1−</m:t>
                               </m:r>
                               <m:r>
                                 <a:rPr lang="en-US" b="0" i="1" smtClean="0">
@@ -21538,7 +21220,7 @@
             </p:txBody>
           </p:sp>
         </mc:Choice>
-        <mc:Fallback>
+        <mc:Fallback xmlns="">
           <p:sp>
             <p:nvSpPr>
               <p:cNvPr id="3" name="Content Placeholder 2">

</xml_diff>